<commit_message>
feat(templates): upgrade presentation decks with editorial photos and contrast cards
</commit_message>
<xml_diff>
--- a/src/creative_mcp/editor/assets/eksekutif-pitch-deck-canva-template.pptx
+++ b/src/creative_mcp/editor/assets/eksekutif-pitch-deck-canva-template.pptx
@@ -3088,7 +3088,7 @@
     <p:bg>
       <p:bgPr>
         <a:solidFill>
-          <a:srgbClr val="111111"/>
+          <a:srgbClr val="0B0F19"/>
         </a:solidFill>
         <a:effectLst/>
       </p:bgPr>
@@ -3152,7 +3152,7 @@
         <p:spPr>
           <a:xfrm>
             <a:off x="619125" y="585787"/>
-            <a:ext cx="8524875" cy="285750"/>
+            <a:ext cx="3810000" cy="285750"/>
           </a:xfrm>
           <a:prstGeom prst="rect">
             <a:avLst/>
@@ -3169,7 +3169,7 @@
             <a:r>
               <a:rPr sz="1125" b="1">
                 <a:solidFill>
-                  <a:srgbClr val="FFD400"/>
+                  <a:srgbClr val="0EA5E9"/>
                 </a:solidFill>
                 <a:latin typeface="Montserrat"/>
               </a:rPr>
@@ -3213,41 +3213,31 @@
           </a:p>
         </p:txBody>
       </p:sp>
-      <p:sp>
-        <p:nvSpPr>
-          <p:cNvPr id="5" name="TextBox 4"/>
-          <p:cNvSpPr txBox="1"/>
-          <p:nvPr/>
-        </p:nvSpPr>
-        <p:spPr>
-          <a:xfrm>
-            <a:off x="619125" y="2880360"/>
-            <a:ext cx="11887200" cy="1714500"/>
-          </a:xfrm>
-          <a:prstGeom prst="rect">
-            <a:avLst/>
-          </a:prstGeom>
-          <a:noFill/>
-        </p:spPr>
-        <p:txBody>
-          <a:bodyPr wrap="square" anchor="t">
-            <a:spAutoFit/>
-          </a:bodyPr>
-          <a:lstStyle/>
-          <a:p>
-            <a:pPr algn="l"/>
-            <a:r>
-              <a:rPr sz="3900" b="1">
-                <a:solidFill>
-                  <a:srgbClr val="F8FAFC"/>
-                </a:solidFill>
-                <a:latin typeface="Montserrat"/>
-              </a:rPr>
-              <a:t>Platform Ekosistem Digital 2026</a:t>
-            </a:r>
-          </a:p>
-        </p:txBody>
-      </p:sp>
+      <p:pic>
+        <p:nvPicPr>
+          <p:cNvPr id="5" name="Picture 4" descr="executive_hero.jpg"/>
+          <p:cNvPicPr>
+            <a:picLocks noChangeAspect="1"/>
+          </p:cNvPicPr>
+          <p:nvPr/>
+        </p:nvPicPr>
+        <p:blipFill>
+          <a:blip r:embed="rId2"/>
+          <a:srcRect l="17536" r="17536"/>
+          <a:stretch>
+            <a:fillRect/>
+          </a:stretch>
+        </p:blipFill>
+        <p:spPr>
+          <a:xfrm>
+            <a:off x="9770745" y="2263140"/>
+            <a:ext cx="7898129" cy="6789420"/>
+          </a:xfrm>
+          <a:prstGeom prst="rect">
+            <a:avLst/>
+          </a:prstGeom>
+        </p:spPr>
+      </p:pic>
       <p:sp>
         <p:nvSpPr>
           <p:cNvPr id="6" name="Rectangle 5"/>
@@ -3256,17 +3246,17 @@
         </p:nvSpPr>
         <p:spPr>
           <a:xfrm>
-            <a:off x="619125" y="5657850"/>
-            <a:ext cx="38100" cy="1047750"/>
-          </a:xfrm>
-          <a:prstGeom prst="rect">
-            <a:avLst/>
-          </a:prstGeom>
-          <a:solidFill>
-            <a:srgbClr val="FFD400"/>
-          </a:solidFill>
-          <a:ln>
-            <a:noFill/>
+            <a:off x="9770745" y="2263140"/>
+            <a:ext cx="7898129" cy="6789420"/>
+          </a:xfrm>
+          <a:prstGeom prst="rect">
+            <a:avLst/>
+          </a:prstGeom>
+          <a:noFill/>
+          <a:ln w="9525">
+            <a:solidFill>
+              <a:srgbClr val="334155"/>
+            </a:solidFill>
           </a:ln>
         </p:spPr>
         <p:style>
@@ -3293,14 +3283,59 @@
       </p:sp>
       <p:sp>
         <p:nvSpPr>
-          <p:cNvPr id="7" name="TextBox 6"/>
+          <p:cNvPr id="7" name="Rectangle 6"/>
+          <p:cNvSpPr/>
+          <p:nvPr/>
+        </p:nvSpPr>
+        <p:spPr>
+          <a:xfrm>
+            <a:off x="9961245" y="8442960"/>
+            <a:ext cx="2476500" cy="419100"/>
+          </a:xfrm>
+          <a:prstGeom prst="rect">
+            <a:avLst/>
+          </a:prstGeom>
+          <a:solidFill>
+            <a:srgbClr val="0A0E17"/>
+          </a:solidFill>
+          <a:ln w="9525">
+            <a:solidFill>
+              <a:srgbClr val="0EA5E9"/>
+            </a:solidFill>
+          </a:ln>
+        </p:spPr>
+        <p:style>
+          <a:lnRef idx="1">
+            <a:schemeClr val="accent1"/>
+          </a:lnRef>
+          <a:fillRef idx="3">
+            <a:schemeClr val="accent1"/>
+          </a:fillRef>
+          <a:effectRef idx="2">
+            <a:schemeClr val="accent1"/>
+          </a:effectRef>
+          <a:fontRef idx="minor">
+            <a:schemeClr val="lt1"/>
+          </a:fontRef>
+        </p:style>
+        <p:txBody>
+          <a:bodyPr rtlCol="0" anchor="ctr"/>
+          <a:lstStyle/>
+          <a:p>
+            <a:pPr algn="ctr"/>
+          </a:p>
+        </p:txBody>
+      </p:sp>
+      <p:sp>
+        <p:nvSpPr>
+          <p:cNvPr id="8" name="TextBox 7"/>
           <p:cNvSpPr txBox="1"/>
           <p:nvPr/>
         </p:nvSpPr>
         <p:spPr>
           <a:xfrm>
-            <a:off x="847725" y="5657850"/>
-            <a:ext cx="10607040" cy="1047750"/>
+            <a:off x="9961245" y="8519160"/>
+            <a:ext cx="2476500" cy="285750"/>
           </a:xfrm>
           <a:prstGeom prst="rect">
             <a:avLst/>
@@ -3313,29 +3348,142 @@
           </a:bodyPr>
           <a:lstStyle/>
           <a:p>
-            <a:pPr algn="l"/>
-            <a:r>
-              <a:rPr sz="1500" b="0">
-                <a:solidFill>
-                  <a:srgbClr val="94A3B8"/>
+            <a:pPr algn="ctr"/>
+            <a:r>
+              <a:rPr sz="975" b="1">
+                <a:solidFill>
+                  <a:srgbClr val="0EA5E9"/>
                 </a:solidFill>
                 <a:latin typeface="Montserrat"/>
               </a:rPr>
-              <a:t>Arsitektur Cloud Skalabel dan Solusi Otomasi Korporat Terintegrasi</a:t>
-            </a:r>
-          </a:p>
-        </p:txBody>
-      </p:sp>
-      <p:sp>
-        <p:nvSpPr>
-          <p:cNvPr id="8" name="Rectangle 7"/>
+              <a:t>SERI A // Rp 50 MILIAR</a:t>
+            </a:r>
+          </a:p>
+        </p:txBody>
+      </p:sp>
+      <p:sp>
+        <p:nvSpPr>
+          <p:cNvPr id="9" name="TextBox 8"/>
+          <p:cNvSpPr txBox="1"/>
+          <p:nvPr/>
+        </p:nvSpPr>
+        <p:spPr>
+          <a:xfrm>
+            <a:off x="619125" y="2571750"/>
+            <a:ext cx="8675370" cy="1905000"/>
+          </a:xfrm>
+          <a:prstGeom prst="rect">
+            <a:avLst/>
+          </a:prstGeom>
+          <a:noFill/>
+        </p:spPr>
+        <p:txBody>
+          <a:bodyPr wrap="square" anchor="t">
+            <a:spAutoFit/>
+          </a:bodyPr>
+          <a:lstStyle/>
+          <a:p>
+            <a:pPr algn="l"/>
+            <a:r>
+              <a:rPr sz="3600" b="1">
+                <a:solidFill>
+                  <a:srgbClr val="F8FAFC"/>
+                </a:solidFill>
+                <a:latin typeface="Montserrat"/>
+              </a:rPr>
+              <a:t>EKOSISTEM DIGITAL NUSANTARA 2026</a:t>
+            </a:r>
+          </a:p>
+        </p:txBody>
+      </p:sp>
+      <p:sp>
+        <p:nvSpPr>
+          <p:cNvPr id="10" name="Rectangle 9"/>
           <p:cNvSpPr/>
           <p:nvPr/>
         </p:nvSpPr>
         <p:spPr>
           <a:xfrm>
+            <a:off x="619125" y="5657850"/>
+            <a:ext cx="38100" cy="1047750"/>
+          </a:xfrm>
+          <a:prstGeom prst="rect">
+            <a:avLst/>
+          </a:prstGeom>
+          <a:solidFill>
+            <a:srgbClr val="0EA5E9"/>
+          </a:solidFill>
+          <a:ln>
+            <a:noFill/>
+          </a:ln>
+        </p:spPr>
+        <p:style>
+          <a:lnRef idx="1">
+            <a:schemeClr val="accent1"/>
+          </a:lnRef>
+          <a:fillRef idx="3">
+            <a:schemeClr val="accent1"/>
+          </a:fillRef>
+          <a:effectRef idx="2">
+            <a:schemeClr val="accent1"/>
+          </a:effectRef>
+          <a:fontRef idx="minor">
+            <a:schemeClr val="lt1"/>
+          </a:fontRef>
+        </p:style>
+        <p:txBody>
+          <a:bodyPr rtlCol="0" anchor="ctr"/>
+          <a:lstStyle/>
+          <a:p>
+            <a:pPr algn="ctr"/>
+          </a:p>
+        </p:txBody>
+      </p:sp>
+      <p:sp>
+        <p:nvSpPr>
+          <p:cNvPr id="11" name="TextBox 10"/>
+          <p:cNvSpPr txBox="1"/>
+          <p:nvPr/>
+        </p:nvSpPr>
+        <p:spPr>
+          <a:xfrm>
+            <a:off x="847725" y="5657850"/>
+            <a:ext cx="8446770" cy="1047750"/>
+          </a:xfrm>
+          <a:prstGeom prst="rect">
+            <a:avLst/>
+          </a:prstGeom>
+          <a:noFill/>
+        </p:spPr>
+        <p:txBody>
+          <a:bodyPr wrap="square" anchor="t">
+            <a:spAutoFit/>
+          </a:bodyPr>
+          <a:lstStyle/>
+          <a:p>
+            <a:pPr algn="l"/>
+            <a:r>
+              <a:rPr sz="1500" b="0">
+                <a:solidFill>
+                  <a:srgbClr val="94A3B8"/>
+                </a:solidFill>
+                <a:latin typeface="Montserrat"/>
+              </a:rPr>
+              <a:t>Arsitektur Platform Skalabel dengan Keamanan Mutakhir dan Efisiensi Operasional Teruji</a:t>
+            </a:r>
+          </a:p>
+        </p:txBody>
+      </p:sp>
+      <p:sp>
+        <p:nvSpPr>
+          <p:cNvPr id="12" name="Rectangle 11"/>
+          <p:cNvSpPr/>
+          <p:nvPr/>
+        </p:nvSpPr>
+        <p:spPr>
+          <a:xfrm>
             <a:off x="619125" y="9096375"/>
-            <a:ext cx="17049750" cy="9525"/>
+            <a:ext cx="8865870" cy="9525"/>
           </a:xfrm>
           <a:prstGeom prst="rect">
             <a:avLst/>
@@ -3371,14 +3519,14 @@
       </p:sp>
       <p:sp>
         <p:nvSpPr>
-          <p:cNvPr id="9" name="TextBox 8"/>
+          <p:cNvPr id="13" name="TextBox 12"/>
           <p:cNvSpPr txBox="1"/>
           <p:nvPr/>
         </p:nvSpPr>
         <p:spPr>
           <a:xfrm>
             <a:off x="619125" y="9286875"/>
-            <a:ext cx="9144000" cy="285750"/>
+            <a:ext cx="6770370" cy="285750"/>
           </a:xfrm>
           <a:prstGeom prst="rect">
             <a:avLst/>
@@ -3406,20 +3554,20 @@
       </p:sp>
       <p:sp>
         <p:nvSpPr>
-          <p:cNvPr id="10" name="Rectangle 9"/>
+          <p:cNvPr id="14" name="Rectangle 13"/>
           <p:cNvSpPr/>
           <p:nvPr/>
         </p:nvSpPr>
         <p:spPr>
           <a:xfrm>
-            <a:off x="15382875" y="9191625"/>
-            <a:ext cx="2286000" cy="419100"/>
+            <a:off x="7579995" y="9191625"/>
+            <a:ext cx="1905000" cy="419100"/>
           </a:xfrm>
           <a:prstGeom prst="rect">
             <a:avLst/>
           </a:prstGeom>
           <a:solidFill>
-            <a:srgbClr val="FFD400"/>
+            <a:srgbClr val="0EA5E9"/>
           </a:solidFill>
           <a:ln>
             <a:noFill/>
@@ -3449,14 +3597,14 @@
       </p:sp>
       <p:sp>
         <p:nvSpPr>
-          <p:cNvPr id="11" name="TextBox 10"/>
+          <p:cNvPr id="15" name="TextBox 14"/>
           <p:cNvSpPr txBox="1"/>
           <p:nvPr/>
         </p:nvSpPr>
         <p:spPr>
           <a:xfrm>
-            <a:off x="15382875" y="9267825"/>
-            <a:ext cx="2286000" cy="285750"/>
+            <a:off x="7579995" y="9267825"/>
+            <a:ext cx="1905000" cy="285750"/>
           </a:xfrm>
           <a:prstGeom prst="rect">
             <a:avLst/>
@@ -3496,7 +3644,7 @@
     <p:bg>
       <p:bgPr>
         <a:solidFill>
-          <a:srgbClr val="111111"/>
+          <a:srgbClr val="0B0F19"/>
         </a:solidFill>
         <a:effectLst/>
       </p:bgPr>
@@ -3577,7 +3725,7 @@
             <a:r>
               <a:rPr sz="1050" b="1">
                 <a:solidFill>
-                  <a:srgbClr val="FF3B30"/>
+                  <a:srgbClr val="F59E0B"/>
                 </a:solidFill>
                 <a:latin typeface="Montserrat"/>
               </a:rPr>
@@ -3670,7 +3818,9 @@
           <a:prstGeom prst="rect">
             <a:avLst/>
           </a:prstGeom>
-          <a:noFill/>
+          <a:solidFill>
+            <a:srgbClr val="162032"/>
+          </a:solidFill>
           <a:ln w="9525">
             <a:solidFill>
               <a:srgbClr val="334155"/>
@@ -3701,14 +3851,100 @@
       </p:sp>
       <p:sp>
         <p:nvSpPr>
-          <p:cNvPr id="7" name="TextBox 6"/>
+          <p:cNvPr id="7" name="Rectangle 6"/>
+          <p:cNvSpPr/>
+          <p:nvPr/>
+        </p:nvSpPr>
+        <p:spPr>
+          <a:xfrm>
+            <a:off x="619125" y="3600450"/>
+            <a:ext cx="8382000" cy="28575"/>
+          </a:xfrm>
+          <a:prstGeom prst="rect">
+            <a:avLst/>
+          </a:prstGeom>
+          <a:solidFill>
+            <a:srgbClr val="0EA5E9"/>
+          </a:solidFill>
+          <a:ln>
+            <a:noFill/>
+          </a:ln>
+        </p:spPr>
+        <p:style>
+          <a:lnRef idx="1">
+            <a:schemeClr val="accent1"/>
+          </a:lnRef>
+          <a:fillRef idx="3">
+            <a:schemeClr val="accent1"/>
+          </a:fillRef>
+          <a:effectRef idx="2">
+            <a:schemeClr val="accent1"/>
+          </a:effectRef>
+          <a:fontRef idx="minor">
+            <a:schemeClr val="lt1"/>
+          </a:fontRef>
+        </p:style>
+        <p:txBody>
+          <a:bodyPr rtlCol="0" anchor="ctr"/>
+          <a:lstStyle/>
+          <a:p>
+            <a:pPr algn="ctr"/>
+          </a:p>
+        </p:txBody>
+      </p:sp>
+      <p:sp>
+        <p:nvSpPr>
+          <p:cNvPr id="8" name="Rectangle 7"/>
+          <p:cNvSpPr/>
+          <p:nvPr/>
+        </p:nvSpPr>
+        <p:spPr>
+          <a:xfrm>
+            <a:off x="847725" y="3790950"/>
+            <a:ext cx="419100" cy="304800"/>
+          </a:xfrm>
+          <a:prstGeom prst="rect">
+            <a:avLst/>
+          </a:prstGeom>
+          <a:solidFill>
+            <a:srgbClr val="0EA5E9"/>
+          </a:solidFill>
+          <a:ln>
+            <a:noFill/>
+          </a:ln>
+        </p:spPr>
+        <p:style>
+          <a:lnRef idx="1">
+            <a:schemeClr val="accent1"/>
+          </a:lnRef>
+          <a:fillRef idx="3">
+            <a:schemeClr val="accent1"/>
+          </a:fillRef>
+          <a:effectRef idx="2">
+            <a:schemeClr val="accent1"/>
+          </a:effectRef>
+          <a:fontRef idx="minor">
+            <a:schemeClr val="lt1"/>
+          </a:fontRef>
+        </p:style>
+        <p:txBody>
+          <a:bodyPr rtlCol="0" anchor="ctr"/>
+          <a:lstStyle/>
+          <a:p>
+            <a:pPr algn="ctr"/>
+          </a:p>
+        </p:txBody>
+      </p:sp>
+      <p:sp>
+        <p:nvSpPr>
+          <p:cNvPr id="9" name="TextBox 8"/>
           <p:cNvSpPr txBox="1"/>
           <p:nvPr/>
         </p:nvSpPr>
         <p:spPr>
           <a:xfrm>
-            <a:off x="847725" y="3790950"/>
-            <a:ext cx="476250" cy="333375"/>
+            <a:off x="847725" y="3829050"/>
+            <a:ext cx="419100" cy="266700"/>
           </a:xfrm>
           <a:prstGeom prst="rect">
             <a:avLst/>
@@ -3721,11 +3957,11 @@
           </a:bodyPr>
           <a:lstStyle/>
           <a:p>
-            <a:pPr algn="l"/>
-            <a:r>
-              <a:rPr sz="1650" b="1">
-                <a:solidFill>
-                  <a:srgbClr val="FFD400"/>
+            <a:pPr algn="ctr"/>
+            <a:r>
+              <a:rPr sz="1050" b="1">
+                <a:solidFill>
+                  <a:srgbClr val="FFFFFF"/>
                 </a:solidFill>
                 <a:latin typeface="Montserrat"/>
               </a:rPr>
@@ -3736,13 +3972,13 @@
       </p:sp>
       <p:sp>
         <p:nvSpPr>
-          <p:cNvPr id="8" name="TextBox 7"/>
+          <p:cNvPr id="10" name="TextBox 9"/>
           <p:cNvSpPr txBox="1"/>
           <p:nvPr/>
         </p:nvSpPr>
         <p:spPr>
           <a:xfrm>
-            <a:off x="1381125" y="3790950"/>
+            <a:off x="1381125" y="3810000"/>
             <a:ext cx="7429500" cy="333375"/>
           </a:xfrm>
           <a:prstGeom prst="rect">
@@ -3771,13 +4007,13 @@
       </p:sp>
       <p:sp>
         <p:nvSpPr>
-          <p:cNvPr id="9" name="Rectangle 8"/>
+          <p:cNvPr id="11" name="Rectangle 10"/>
           <p:cNvSpPr/>
           <p:nvPr/>
         </p:nvSpPr>
         <p:spPr>
           <a:xfrm>
-            <a:off x="847725" y="4191000"/>
+            <a:off x="847725" y="444"/>
             <a:ext cx="7924800" cy="9525"/>
           </a:xfrm>
           <a:prstGeom prst="rect">
@@ -3814,13 +4050,13 @@
       </p:sp>
       <p:sp>
         <p:nvSpPr>
-          <p:cNvPr id="10" name="TextBox 9"/>
+          <p:cNvPr id="12" name="TextBox 11"/>
           <p:cNvSpPr txBox="1"/>
           <p:nvPr/>
         </p:nvSpPr>
         <p:spPr>
           <a:xfrm>
-            <a:off x="847725" y="4305300"/>
+            <a:off x="847725" y="4343400"/>
             <a:ext cx="7924800" cy="762000"/>
           </a:xfrm>
           <a:prstGeom prst="rect">
@@ -3849,7 +4085,7 @@
       </p:sp>
       <p:sp>
         <p:nvSpPr>
-          <p:cNvPr id="11" name="Rectangle 10"/>
+          <p:cNvPr id="13" name="Rectangle 12"/>
           <p:cNvSpPr/>
           <p:nvPr/>
         </p:nvSpPr>
@@ -3861,7 +4097,9 @@
           <a:prstGeom prst="rect">
             <a:avLst/>
           </a:prstGeom>
-          <a:noFill/>
+          <a:solidFill>
+            <a:srgbClr val="162032"/>
+          </a:solidFill>
           <a:ln w="9525">
             <a:solidFill>
               <a:srgbClr val="334155"/>
@@ -3892,14 +4130,100 @@
       </p:sp>
       <p:sp>
         <p:nvSpPr>
-          <p:cNvPr id="12" name="TextBox 11"/>
+          <p:cNvPr id="14" name="Rectangle 13"/>
+          <p:cNvSpPr/>
+          <p:nvPr/>
+        </p:nvSpPr>
+        <p:spPr>
+          <a:xfrm>
+            <a:off x="9286875" y="3600450"/>
+            <a:ext cx="8382000" cy="28575"/>
+          </a:xfrm>
+          <a:prstGeom prst="rect">
+            <a:avLst/>
+          </a:prstGeom>
+          <a:solidFill>
+            <a:srgbClr val="F59E0B"/>
+          </a:solidFill>
+          <a:ln>
+            <a:noFill/>
+          </a:ln>
+        </p:spPr>
+        <p:style>
+          <a:lnRef idx="1">
+            <a:schemeClr val="accent1"/>
+          </a:lnRef>
+          <a:fillRef idx="3">
+            <a:schemeClr val="accent1"/>
+          </a:fillRef>
+          <a:effectRef idx="2">
+            <a:schemeClr val="accent1"/>
+          </a:effectRef>
+          <a:fontRef idx="minor">
+            <a:schemeClr val="lt1"/>
+          </a:fontRef>
+        </p:style>
+        <p:txBody>
+          <a:bodyPr rtlCol="0" anchor="ctr"/>
+          <a:lstStyle/>
+          <a:p>
+            <a:pPr algn="ctr"/>
+          </a:p>
+        </p:txBody>
+      </p:sp>
+      <p:sp>
+        <p:nvSpPr>
+          <p:cNvPr id="15" name="Rectangle 14"/>
+          <p:cNvSpPr/>
+          <p:nvPr/>
+        </p:nvSpPr>
+        <p:spPr>
+          <a:xfrm>
+            <a:off x="9515475" y="3790950"/>
+            <a:ext cx="419100" cy="304800"/>
+          </a:xfrm>
+          <a:prstGeom prst="rect">
+            <a:avLst/>
+          </a:prstGeom>
+          <a:solidFill>
+            <a:srgbClr val="F59E0B"/>
+          </a:solidFill>
+          <a:ln>
+            <a:noFill/>
+          </a:ln>
+        </p:spPr>
+        <p:style>
+          <a:lnRef idx="1">
+            <a:schemeClr val="accent1"/>
+          </a:lnRef>
+          <a:fillRef idx="3">
+            <a:schemeClr val="accent1"/>
+          </a:fillRef>
+          <a:effectRef idx="2">
+            <a:schemeClr val="accent1"/>
+          </a:effectRef>
+          <a:fontRef idx="minor">
+            <a:schemeClr val="lt1"/>
+          </a:fontRef>
+        </p:style>
+        <p:txBody>
+          <a:bodyPr rtlCol="0" anchor="ctr"/>
+          <a:lstStyle/>
+          <a:p>
+            <a:pPr algn="ctr"/>
+          </a:p>
+        </p:txBody>
+      </p:sp>
+      <p:sp>
+        <p:nvSpPr>
+          <p:cNvPr id="16" name="TextBox 15"/>
           <p:cNvSpPr txBox="1"/>
           <p:nvPr/>
         </p:nvSpPr>
         <p:spPr>
           <a:xfrm>
-            <a:off x="9515475" y="3790950"/>
-            <a:ext cx="476250" cy="333375"/>
+            <a:off x="9515475" y="3829050"/>
+            <a:ext cx="419100" cy="266700"/>
           </a:xfrm>
           <a:prstGeom prst="rect">
             <a:avLst/>
@@ -3912,11 +4236,11 @@
           </a:bodyPr>
           <a:lstStyle/>
           <a:p>
-            <a:pPr algn="l"/>
-            <a:r>
-              <a:rPr sz="1650" b="1">
-                <a:solidFill>
-                  <a:srgbClr val="FFD400"/>
+            <a:pPr algn="ctr"/>
+            <a:r>
+              <a:rPr sz="1050" b="1">
+                <a:solidFill>
+                  <a:srgbClr val="FFFFFF"/>
                 </a:solidFill>
                 <a:latin typeface="Montserrat"/>
               </a:rPr>
@@ -3927,13 +4251,13 @@
       </p:sp>
       <p:sp>
         <p:nvSpPr>
-          <p:cNvPr id="13" name="TextBox 12"/>
+          <p:cNvPr id="17" name="TextBox 16"/>
           <p:cNvSpPr txBox="1"/>
           <p:nvPr/>
         </p:nvSpPr>
         <p:spPr>
           <a:xfrm>
-            <a:off x="10048875" y="3790950"/>
+            <a:off x="10048875" y="3810000"/>
             <a:ext cx="7429500" cy="333375"/>
           </a:xfrm>
           <a:prstGeom prst="rect">
@@ -3962,13 +4286,13 @@
       </p:sp>
       <p:sp>
         <p:nvSpPr>
-          <p:cNvPr id="14" name="Rectangle 13"/>
+          <p:cNvPr id="18" name="Rectangle 17"/>
           <p:cNvSpPr/>
           <p:nvPr/>
         </p:nvSpPr>
         <p:spPr>
           <a:xfrm>
-            <a:off x="9515475" y="4191000"/>
+            <a:off x="9515475" y="444"/>
             <a:ext cx="7924800" cy="9525"/>
           </a:xfrm>
           <a:prstGeom prst="rect">
@@ -4005,13 +4329,13 @@
       </p:sp>
       <p:sp>
         <p:nvSpPr>
-          <p:cNvPr id="15" name="TextBox 14"/>
+          <p:cNvPr id="19" name="TextBox 18"/>
           <p:cNvSpPr txBox="1"/>
           <p:nvPr/>
         </p:nvSpPr>
         <p:spPr>
           <a:xfrm>
-            <a:off x="9515475" y="4305300"/>
+            <a:off x="9515475" y="4343400"/>
             <a:ext cx="7924800" cy="762000"/>
           </a:xfrm>
           <a:prstGeom prst="rect">
@@ -4040,7 +4364,7 @@
       </p:sp>
       <p:sp>
         <p:nvSpPr>
-          <p:cNvPr id="16" name="Rectangle 15"/>
+          <p:cNvPr id="20" name="Rectangle 19"/>
           <p:cNvSpPr/>
           <p:nvPr/>
         </p:nvSpPr>
@@ -4052,7 +4376,9 @@
           <a:prstGeom prst="rect">
             <a:avLst/>
           </a:prstGeom>
-          <a:noFill/>
+          <a:solidFill>
+            <a:srgbClr val="162032"/>
+          </a:solidFill>
           <a:ln w="9525">
             <a:solidFill>
               <a:srgbClr val="334155"/>
@@ -4083,14 +4409,100 @@
       </p:sp>
       <p:sp>
         <p:nvSpPr>
-          <p:cNvPr id="17" name="TextBox 16"/>
+          <p:cNvPr id="21" name="Rectangle 20"/>
+          <p:cNvSpPr/>
+          <p:nvPr/>
+        </p:nvSpPr>
+        <p:spPr>
+          <a:xfrm>
+            <a:off x="619125" y="6503670"/>
+            <a:ext cx="8382000" cy="28575"/>
+          </a:xfrm>
+          <a:prstGeom prst="rect">
+            <a:avLst/>
+          </a:prstGeom>
+          <a:solidFill>
+            <a:srgbClr val="0EA5E9"/>
+          </a:solidFill>
+          <a:ln>
+            <a:noFill/>
+          </a:ln>
+        </p:spPr>
+        <p:style>
+          <a:lnRef idx="1">
+            <a:schemeClr val="accent1"/>
+          </a:lnRef>
+          <a:fillRef idx="3">
+            <a:schemeClr val="accent1"/>
+          </a:fillRef>
+          <a:effectRef idx="2">
+            <a:schemeClr val="accent1"/>
+          </a:effectRef>
+          <a:fontRef idx="minor">
+            <a:schemeClr val="lt1"/>
+          </a:fontRef>
+        </p:style>
+        <p:txBody>
+          <a:bodyPr rtlCol="0" anchor="ctr"/>
+          <a:lstStyle/>
+          <a:p>
+            <a:pPr algn="ctr"/>
+          </a:p>
+        </p:txBody>
+      </p:sp>
+      <p:sp>
+        <p:nvSpPr>
+          <p:cNvPr id="22" name="Rectangle 21"/>
+          <p:cNvSpPr/>
+          <p:nvPr/>
+        </p:nvSpPr>
+        <p:spPr>
+          <a:xfrm>
+            <a:off x="847725" y="6694170"/>
+            <a:ext cx="419100" cy="304800"/>
+          </a:xfrm>
+          <a:prstGeom prst="rect">
+            <a:avLst/>
+          </a:prstGeom>
+          <a:solidFill>
+            <a:srgbClr val="0EA5E9"/>
+          </a:solidFill>
+          <a:ln>
+            <a:noFill/>
+          </a:ln>
+        </p:spPr>
+        <p:style>
+          <a:lnRef idx="1">
+            <a:schemeClr val="accent1"/>
+          </a:lnRef>
+          <a:fillRef idx="3">
+            <a:schemeClr val="accent1"/>
+          </a:fillRef>
+          <a:effectRef idx="2">
+            <a:schemeClr val="accent1"/>
+          </a:effectRef>
+          <a:fontRef idx="minor">
+            <a:schemeClr val="lt1"/>
+          </a:fontRef>
+        </p:style>
+        <p:txBody>
+          <a:bodyPr rtlCol="0" anchor="ctr"/>
+          <a:lstStyle/>
+          <a:p>
+            <a:pPr algn="ctr"/>
+          </a:p>
+        </p:txBody>
+      </p:sp>
+      <p:sp>
+        <p:nvSpPr>
+          <p:cNvPr id="23" name="TextBox 22"/>
           <p:cNvSpPr txBox="1"/>
           <p:nvPr/>
         </p:nvSpPr>
         <p:spPr>
           <a:xfrm>
-            <a:off x="847725" y="6694170"/>
-            <a:ext cx="476250" cy="333375"/>
+            <a:off x="847725" y="6732270"/>
+            <a:ext cx="419100" cy="266700"/>
           </a:xfrm>
           <a:prstGeom prst="rect">
             <a:avLst/>
@@ -4103,11 +4515,11 @@
           </a:bodyPr>
           <a:lstStyle/>
           <a:p>
-            <a:pPr algn="l"/>
-            <a:r>
-              <a:rPr sz="1650" b="1">
-                <a:solidFill>
-                  <a:srgbClr val="FFD400"/>
+            <a:pPr algn="ctr"/>
+            <a:r>
+              <a:rPr sz="1050" b="1">
+                <a:solidFill>
+                  <a:srgbClr val="FFFFFF"/>
                 </a:solidFill>
                 <a:latin typeface="Montserrat"/>
               </a:rPr>
@@ -4118,13 +4530,13 @@
       </p:sp>
       <p:sp>
         <p:nvSpPr>
-          <p:cNvPr id="18" name="TextBox 17"/>
+          <p:cNvPr id="24" name="TextBox 23"/>
           <p:cNvSpPr txBox="1"/>
           <p:nvPr/>
         </p:nvSpPr>
         <p:spPr>
           <a:xfrm>
-            <a:off x="1381125" y="6694170"/>
+            <a:off x="1381125" y="6713220"/>
             <a:ext cx="7429500" cy="333375"/>
           </a:xfrm>
           <a:prstGeom prst="rect">
@@ -4153,13 +4565,13 @@
       </p:sp>
       <p:sp>
         <p:nvSpPr>
-          <p:cNvPr id="19" name="Rectangle 18"/>
+          <p:cNvPr id="25" name="Rectangle 24"/>
           <p:cNvSpPr/>
           <p:nvPr/>
         </p:nvSpPr>
         <p:spPr>
           <a:xfrm>
-            <a:off x="847725" y="7094220"/>
+            <a:off x="847725" y="748"/>
             <a:ext cx="7924800" cy="9525"/>
           </a:xfrm>
           <a:prstGeom prst="rect">
@@ -4196,13 +4608,13 @@
       </p:sp>
       <p:sp>
         <p:nvSpPr>
-          <p:cNvPr id="20" name="TextBox 19"/>
+          <p:cNvPr id="26" name="TextBox 25"/>
           <p:cNvSpPr txBox="1"/>
           <p:nvPr/>
         </p:nvSpPr>
         <p:spPr>
           <a:xfrm>
-            <a:off x="847725" y="7208520"/>
+            <a:off x="847725" y="7246620"/>
             <a:ext cx="7924800" cy="762000"/>
           </a:xfrm>
           <a:prstGeom prst="rect">
@@ -4231,7 +4643,7 @@
       </p:sp>
       <p:sp>
         <p:nvSpPr>
-          <p:cNvPr id="21" name="Rectangle 20"/>
+          <p:cNvPr id="27" name="Rectangle 26"/>
           <p:cNvSpPr/>
           <p:nvPr/>
         </p:nvSpPr>
@@ -4243,7 +4655,9 @@
           <a:prstGeom prst="rect">
             <a:avLst/>
           </a:prstGeom>
-          <a:noFill/>
+          <a:solidFill>
+            <a:srgbClr val="162032"/>
+          </a:solidFill>
           <a:ln w="9525">
             <a:solidFill>
               <a:srgbClr val="334155"/>
@@ -4274,14 +4688,100 @@
       </p:sp>
       <p:sp>
         <p:nvSpPr>
-          <p:cNvPr id="22" name="TextBox 21"/>
+          <p:cNvPr id="28" name="Rectangle 27"/>
+          <p:cNvSpPr/>
+          <p:nvPr/>
+        </p:nvSpPr>
+        <p:spPr>
+          <a:xfrm>
+            <a:off x="9286875" y="6503670"/>
+            <a:ext cx="8382000" cy="28575"/>
+          </a:xfrm>
+          <a:prstGeom prst="rect">
+            <a:avLst/>
+          </a:prstGeom>
+          <a:solidFill>
+            <a:srgbClr val="F59E0B"/>
+          </a:solidFill>
+          <a:ln>
+            <a:noFill/>
+          </a:ln>
+        </p:spPr>
+        <p:style>
+          <a:lnRef idx="1">
+            <a:schemeClr val="accent1"/>
+          </a:lnRef>
+          <a:fillRef idx="3">
+            <a:schemeClr val="accent1"/>
+          </a:fillRef>
+          <a:effectRef idx="2">
+            <a:schemeClr val="accent1"/>
+          </a:effectRef>
+          <a:fontRef idx="minor">
+            <a:schemeClr val="lt1"/>
+          </a:fontRef>
+        </p:style>
+        <p:txBody>
+          <a:bodyPr rtlCol="0" anchor="ctr"/>
+          <a:lstStyle/>
+          <a:p>
+            <a:pPr algn="ctr"/>
+          </a:p>
+        </p:txBody>
+      </p:sp>
+      <p:sp>
+        <p:nvSpPr>
+          <p:cNvPr id="29" name="Rectangle 28"/>
+          <p:cNvSpPr/>
+          <p:nvPr/>
+        </p:nvSpPr>
+        <p:spPr>
+          <a:xfrm>
+            <a:off x="9515475" y="6694170"/>
+            <a:ext cx="419100" cy="304800"/>
+          </a:xfrm>
+          <a:prstGeom prst="rect">
+            <a:avLst/>
+          </a:prstGeom>
+          <a:solidFill>
+            <a:srgbClr val="F59E0B"/>
+          </a:solidFill>
+          <a:ln>
+            <a:noFill/>
+          </a:ln>
+        </p:spPr>
+        <p:style>
+          <a:lnRef idx="1">
+            <a:schemeClr val="accent1"/>
+          </a:lnRef>
+          <a:fillRef idx="3">
+            <a:schemeClr val="accent1"/>
+          </a:fillRef>
+          <a:effectRef idx="2">
+            <a:schemeClr val="accent1"/>
+          </a:effectRef>
+          <a:fontRef idx="minor">
+            <a:schemeClr val="lt1"/>
+          </a:fontRef>
+        </p:style>
+        <p:txBody>
+          <a:bodyPr rtlCol="0" anchor="ctr"/>
+          <a:lstStyle/>
+          <a:p>
+            <a:pPr algn="ctr"/>
+          </a:p>
+        </p:txBody>
+      </p:sp>
+      <p:sp>
+        <p:nvSpPr>
+          <p:cNvPr id="30" name="TextBox 29"/>
           <p:cNvSpPr txBox="1"/>
           <p:nvPr/>
         </p:nvSpPr>
         <p:spPr>
           <a:xfrm>
-            <a:off x="9515475" y="6694170"/>
-            <a:ext cx="476250" cy="333375"/>
+            <a:off x="9515475" y="6732270"/>
+            <a:ext cx="419100" cy="266700"/>
           </a:xfrm>
           <a:prstGeom prst="rect">
             <a:avLst/>
@@ -4294,11 +4794,11 @@
           </a:bodyPr>
           <a:lstStyle/>
           <a:p>
-            <a:pPr algn="l"/>
-            <a:r>
-              <a:rPr sz="1650" b="1">
-                <a:solidFill>
-                  <a:srgbClr val="FFD400"/>
+            <a:pPr algn="ctr"/>
+            <a:r>
+              <a:rPr sz="1050" b="1">
+                <a:solidFill>
+                  <a:srgbClr val="FFFFFF"/>
                 </a:solidFill>
                 <a:latin typeface="Montserrat"/>
               </a:rPr>
@@ -4309,13 +4809,13 @@
       </p:sp>
       <p:sp>
         <p:nvSpPr>
-          <p:cNvPr id="23" name="TextBox 22"/>
+          <p:cNvPr id="31" name="TextBox 30"/>
           <p:cNvSpPr txBox="1"/>
           <p:nvPr/>
         </p:nvSpPr>
         <p:spPr>
           <a:xfrm>
-            <a:off x="10048875" y="6694170"/>
+            <a:off x="10048875" y="6713220"/>
             <a:ext cx="7429500" cy="333375"/>
           </a:xfrm>
           <a:prstGeom prst="rect">
@@ -4344,13 +4844,13 @@
       </p:sp>
       <p:sp>
         <p:nvSpPr>
-          <p:cNvPr id="24" name="Rectangle 23"/>
+          <p:cNvPr id="32" name="Rectangle 31"/>
           <p:cNvSpPr/>
           <p:nvPr/>
         </p:nvSpPr>
         <p:spPr>
           <a:xfrm>
-            <a:off x="9515475" y="7094220"/>
+            <a:off x="9515475" y="748"/>
             <a:ext cx="7924800" cy="9525"/>
           </a:xfrm>
           <a:prstGeom prst="rect">
@@ -4387,13 +4887,13 @@
       </p:sp>
       <p:sp>
         <p:nvSpPr>
-          <p:cNvPr id="25" name="TextBox 24"/>
+          <p:cNvPr id="33" name="TextBox 32"/>
           <p:cNvSpPr txBox="1"/>
           <p:nvPr/>
         </p:nvSpPr>
         <p:spPr>
           <a:xfrm>
-            <a:off x="9515475" y="7208520"/>
+            <a:off x="9515475" y="7246620"/>
             <a:ext cx="7924800" cy="762000"/>
           </a:xfrm>
           <a:prstGeom prst="rect">
@@ -4434,7 +4934,7 @@
     <p:bg>
       <p:bgPr>
         <a:solidFill>
-          <a:srgbClr val="111111"/>
+          <a:srgbClr val="0B0F19"/>
         </a:solidFill>
         <a:effectLst/>
       </p:bgPr>
@@ -4515,7 +5015,7 @@
             <a:r>
               <a:rPr sz="1050" b="1">
                 <a:solidFill>
-                  <a:srgbClr val="FFD400"/>
+                  <a:srgbClr val="0EA5E9"/>
                 </a:solidFill>
                 <a:latin typeface="Montserrat"/>
               </a:rPr>
@@ -4608,10 +5108,12 @@
           <a:prstGeom prst="rect">
             <a:avLst/>
           </a:prstGeom>
-          <a:noFill/>
+          <a:solidFill>
+            <a:srgbClr val="162032"/>
+          </a:solidFill>
           <a:ln w="19050">
             <a:solidFill>
-              <a:srgbClr val="FFD400"/>
+              <a:srgbClr val="0EA5E9"/>
             </a:solidFill>
           </a:ln>
         </p:spPr>
@@ -4663,7 +5165,7 @@
             <a:r>
               <a:rPr sz="1050" b="1">
                 <a:solidFill>
-                  <a:srgbClr val="FFD400"/>
+                  <a:srgbClr val="0EA5E9"/>
                 </a:solidFill>
                 <a:latin typeface="Montserrat"/>
               </a:rPr>
@@ -4717,128 +5219,25 @@
       </p:sp>
       <p:sp>
         <p:nvSpPr>
-          <p:cNvPr id="9" name="TextBox 8"/>
-          <p:cNvSpPr txBox="1"/>
+          <p:cNvPr id="9" name="Rectangle 8"/>
+          <p:cNvSpPr/>
           <p:nvPr/>
         </p:nvSpPr>
         <p:spPr>
           <a:xfrm>
             <a:off x="8793480" y="2263140"/>
-            <a:ext cx="428625" cy="285750"/>
-          </a:xfrm>
-          <a:prstGeom prst="rect">
-            <a:avLst/>
-          </a:prstGeom>
-          <a:noFill/>
-        </p:spPr>
-        <p:txBody>
-          <a:bodyPr wrap="square" anchor="t">
-            <a:spAutoFit/>
-          </a:bodyPr>
-          <a:lstStyle/>
-          <a:p>
-            <a:pPr algn="l"/>
-            <a:r>
-              <a:rPr sz="1650" b="1">
-                <a:solidFill>
-                  <a:srgbClr val="FF3B30"/>
-                </a:solidFill>
-                <a:latin typeface="Montserrat"/>
-              </a:rPr>
-              <a:t>01</a:t>
-            </a:r>
-          </a:p>
-        </p:txBody>
-      </p:sp>
-      <p:sp>
-        <p:nvSpPr>
-          <p:cNvPr id="10" name="TextBox 9"/>
-          <p:cNvSpPr txBox="1"/>
-          <p:nvPr/>
-        </p:nvSpPr>
-        <p:spPr>
-          <a:xfrm>
-            <a:off x="9317355" y="2263140"/>
-            <a:ext cx="8351520" cy="285750"/>
-          </a:xfrm>
-          <a:prstGeom prst="rect">
-            <a:avLst/>
-          </a:prstGeom>
-          <a:noFill/>
-        </p:spPr>
-        <p:txBody>
-          <a:bodyPr wrap="square" anchor="t">
-            <a:spAutoFit/>
-          </a:bodyPr>
-          <a:lstStyle/>
-          <a:p>
-            <a:pPr algn="l"/>
-            <a:r>
-              <a:rPr sz="1575" b="1">
-                <a:solidFill>
-                  <a:srgbClr val="F8FAFC"/>
-                </a:solidFill>
-                <a:latin typeface="Montserrat"/>
-              </a:rPr>
-              <a:t>Skalabilitas Awan Elastis</a:t>
-            </a:r>
-          </a:p>
-        </p:txBody>
-      </p:sp>
-      <p:sp>
-        <p:nvSpPr>
-          <p:cNvPr id="11" name="TextBox 10"/>
-          <p:cNvSpPr txBox="1"/>
-          <p:nvPr/>
-        </p:nvSpPr>
-        <p:spPr>
-          <a:xfrm>
-            <a:off x="9317355" y="2625090"/>
-            <a:ext cx="8351520" cy="571500"/>
-          </a:xfrm>
-          <a:prstGeom prst="rect">
-            <a:avLst/>
-          </a:prstGeom>
-          <a:noFill/>
-        </p:spPr>
-        <p:txBody>
-          <a:bodyPr wrap="square" anchor="t">
-            <a:spAutoFit/>
-          </a:bodyPr>
-          <a:lstStyle/>
-          <a:p>
-            <a:pPr algn="l"/>
-            <a:r>
-              <a:rPr sz="1125" b="0">
-                <a:solidFill>
-                  <a:srgbClr val="94A3B8"/>
-                </a:solidFill>
-                <a:latin typeface="Montserrat"/>
-              </a:rPr>
-              <a:t>Infrastruktur kontainer terdistribusi yang menyesuaikan kapasitas lalu lintas dinamis secara mulus.</a:t>
-            </a:r>
-          </a:p>
-        </p:txBody>
-      </p:sp>
-      <p:sp>
-        <p:nvSpPr>
-          <p:cNvPr id="12" name="Rectangle 11"/>
-          <p:cNvSpPr/>
-          <p:nvPr/>
-        </p:nvSpPr>
-        <p:spPr>
-          <a:xfrm>
-            <a:off x="8793480" y="3263265"/>
-            <a:ext cx="8875395" cy="9525"/>
+            <a:ext cx="8875395" cy="1851660"/>
           </a:xfrm>
           <a:prstGeom prst="rect">
             <a:avLst/>
           </a:prstGeom>
           <a:solidFill>
-            <a:srgbClr val="334155"/>
+            <a:srgbClr val="162032"/>
           </a:solidFill>
-          <a:ln>
-            <a:noFill/>
+          <a:ln w="9525">
+            <a:solidFill>
+              <a:srgbClr val="334155"/>
+            </a:solidFill>
           </a:ln>
         </p:spPr>
         <p:style>
@@ -4865,13 +5264,13 @@
       </p:sp>
       <p:sp>
         <p:nvSpPr>
-          <p:cNvPr id="13" name="TextBox 12"/>
+          <p:cNvPr id="10" name="TextBox 9"/>
           <p:cNvSpPr txBox="1"/>
           <p:nvPr/>
         </p:nvSpPr>
         <p:spPr>
           <a:xfrm>
-            <a:off x="8793480" y="4526280"/>
+            <a:off x="8983980" y="2415540"/>
             <a:ext cx="428625" cy="285750"/>
           </a:xfrm>
           <a:prstGeom prst="rect">
@@ -4889,25 +5288,25 @@
             <a:r>
               <a:rPr sz="1650" b="1">
                 <a:solidFill>
-                  <a:srgbClr val="FF3B30"/>
+                  <a:srgbClr val="F59E0B"/>
                 </a:solidFill>
                 <a:latin typeface="Montserrat"/>
               </a:rPr>
-              <a:t>02</a:t>
-            </a:r>
-          </a:p>
-        </p:txBody>
-      </p:sp>
-      <p:sp>
-        <p:nvSpPr>
-          <p:cNvPr id="14" name="TextBox 13"/>
+              <a:t>01</a:t>
+            </a:r>
+          </a:p>
+        </p:txBody>
+      </p:sp>
+      <p:sp>
+        <p:nvSpPr>
+          <p:cNvPr id="11" name="TextBox 10"/>
           <p:cNvSpPr txBox="1"/>
           <p:nvPr/>
         </p:nvSpPr>
         <p:spPr>
           <a:xfrm>
-            <a:off x="9317355" y="4526280"/>
-            <a:ext cx="8351520" cy="285750"/>
+            <a:off x="9507855" y="2415540"/>
+            <a:ext cx="7970520" cy="285750"/>
           </a:xfrm>
           <a:prstGeom prst="rect">
             <a:avLst/>
@@ -4928,21 +5327,21 @@
                 </a:solidFill>
                 <a:latin typeface="Montserrat"/>
               </a:rPr>
-              <a:t>Enkripsi &amp; Tata Kelola Standar Global</a:t>
-            </a:r>
-          </a:p>
-        </p:txBody>
-      </p:sp>
-      <p:sp>
-        <p:nvSpPr>
-          <p:cNvPr id="15" name="TextBox 14"/>
+              <a:t>Skalabilitas Awan Elastis</a:t>
+            </a:r>
+          </a:p>
+        </p:txBody>
+      </p:sp>
+      <p:sp>
+        <p:nvSpPr>
+          <p:cNvPr id="12" name="TextBox 11"/>
           <p:cNvSpPr txBox="1"/>
           <p:nvPr/>
         </p:nvSpPr>
         <p:spPr>
           <a:xfrm>
-            <a:off x="9317355" y="4888230"/>
-            <a:ext cx="8351520" cy="571500"/>
+            <a:off x="9507855" y="2758440"/>
+            <a:ext cx="7970520" cy="571500"/>
           </a:xfrm>
           <a:prstGeom prst="rect">
             <a:avLst/>
@@ -4963,30 +5362,32 @@
                 </a:solidFill>
                 <a:latin typeface="Montserrat"/>
               </a:rPr>
-              <a:t>Protokol perlindungan data berstandar enterprise dengan jejak audit komprehensif.</a:t>
-            </a:r>
-          </a:p>
-        </p:txBody>
-      </p:sp>
-      <p:sp>
-        <p:nvSpPr>
-          <p:cNvPr id="16" name="Rectangle 15"/>
+              <a:t>Infrastruktur kontainer terdistribusi yang menyesuaikan kapasitas lalu lintas dinamis secara mulus.</a:t>
+            </a:r>
+          </a:p>
+        </p:txBody>
+      </p:sp>
+      <p:sp>
+        <p:nvSpPr>
+          <p:cNvPr id="13" name="Rectangle 12"/>
           <p:cNvSpPr/>
           <p:nvPr/>
         </p:nvSpPr>
         <p:spPr>
           <a:xfrm>
-            <a:off x="8793480" y="5526405"/>
-            <a:ext cx="8875395" cy="9525"/>
+            <a:off x="8793480" y="4526280"/>
+            <a:ext cx="8875395" cy="1851660"/>
           </a:xfrm>
           <a:prstGeom prst="rect">
             <a:avLst/>
           </a:prstGeom>
           <a:solidFill>
-            <a:srgbClr val="334155"/>
+            <a:srgbClr val="162032"/>
           </a:solidFill>
-          <a:ln>
-            <a:noFill/>
+          <a:ln w="9525">
+            <a:solidFill>
+              <a:srgbClr val="334155"/>
+            </a:solidFill>
           </a:ln>
         </p:spPr>
         <p:style>
@@ -5013,13 +5414,13 @@
       </p:sp>
       <p:sp>
         <p:nvSpPr>
-          <p:cNvPr id="17" name="TextBox 16"/>
+          <p:cNvPr id="14" name="TextBox 13"/>
           <p:cNvSpPr txBox="1"/>
           <p:nvPr/>
         </p:nvSpPr>
         <p:spPr>
           <a:xfrm>
-            <a:off x="8793480" y="6789420"/>
+            <a:off x="8983980" y="4678680"/>
             <a:ext cx="428625" cy="285750"/>
           </a:xfrm>
           <a:prstGeom prst="rect">
@@ -5037,25 +5438,25 @@
             <a:r>
               <a:rPr sz="1650" b="1">
                 <a:solidFill>
-                  <a:srgbClr val="FF3B30"/>
+                  <a:srgbClr val="F59E0B"/>
                 </a:solidFill>
                 <a:latin typeface="Montserrat"/>
               </a:rPr>
-              <a:t>03</a:t>
-            </a:r>
-          </a:p>
-        </p:txBody>
-      </p:sp>
-      <p:sp>
-        <p:nvSpPr>
-          <p:cNvPr id="18" name="TextBox 17"/>
+              <a:t>02</a:t>
+            </a:r>
+          </a:p>
+        </p:txBody>
+      </p:sp>
+      <p:sp>
+        <p:nvSpPr>
+          <p:cNvPr id="15" name="TextBox 14"/>
           <p:cNvSpPr txBox="1"/>
           <p:nvPr/>
         </p:nvSpPr>
         <p:spPr>
           <a:xfrm>
-            <a:off x="9317355" y="6789420"/>
-            <a:ext cx="8351520" cy="285750"/>
+            <a:off x="9507855" y="4678680"/>
+            <a:ext cx="7970520" cy="285750"/>
           </a:xfrm>
           <a:prstGeom prst="rect">
             <a:avLst/>
@@ -5076,21 +5477,21 @@
                 </a:solidFill>
                 <a:latin typeface="Montserrat"/>
               </a:rPr>
-              <a:t>Konektor API Instan</a:t>
-            </a:r>
-          </a:p>
-        </p:txBody>
-      </p:sp>
-      <p:sp>
-        <p:nvSpPr>
-          <p:cNvPr id="19" name="TextBox 18"/>
+              <a:t>Enkripsi &amp; Tata Kelola Standar Global</a:t>
+            </a:r>
+          </a:p>
+        </p:txBody>
+      </p:sp>
+      <p:sp>
+        <p:nvSpPr>
+          <p:cNvPr id="16" name="TextBox 15"/>
           <p:cNvSpPr txBox="1"/>
           <p:nvPr/>
         </p:nvSpPr>
         <p:spPr>
           <a:xfrm>
-            <a:off x="9317355" y="7151370"/>
-            <a:ext cx="8351520" cy="571500"/>
+            <a:off x="9507855" y="5021580"/>
+            <a:ext cx="7970520" cy="571500"/>
           </a:xfrm>
           <a:prstGeom prst="rect">
             <a:avLst/>
@@ -5111,30 +5512,32 @@
                 </a:solidFill>
                 <a:latin typeface="Montserrat"/>
               </a:rPr>
-              <a:t>Integrasi modular yang mudah disematkan pada sistem yang sedang beroperasi tanpa penghentian layanan.</a:t>
-            </a:r>
-          </a:p>
-        </p:txBody>
-      </p:sp>
-      <p:sp>
-        <p:nvSpPr>
-          <p:cNvPr id="20" name="Rectangle 19"/>
+              <a:t>Protokol perlindungan data berstandar enterprise dengan jejak audit komprehensif.</a:t>
+            </a:r>
+          </a:p>
+        </p:txBody>
+      </p:sp>
+      <p:sp>
+        <p:nvSpPr>
+          <p:cNvPr id="17" name="Rectangle 16"/>
           <p:cNvSpPr/>
           <p:nvPr/>
         </p:nvSpPr>
         <p:spPr>
           <a:xfrm>
-            <a:off x="8793480" y="7789545"/>
-            <a:ext cx="8875395" cy="9525"/>
+            <a:off x="8793480" y="6789420"/>
+            <a:ext cx="8875395" cy="1851660"/>
           </a:xfrm>
           <a:prstGeom prst="rect">
             <a:avLst/>
           </a:prstGeom>
           <a:solidFill>
-            <a:srgbClr val="334155"/>
+            <a:srgbClr val="162032"/>
           </a:solidFill>
-          <a:ln>
-            <a:noFill/>
+          <a:ln w="9525">
+            <a:solidFill>
+              <a:srgbClr val="334155"/>
+            </a:solidFill>
           </a:ln>
         </p:spPr>
         <p:style>
@@ -5156,6 +5559,111 @@
           <a:lstStyle/>
           <a:p>
             <a:pPr algn="ctr"/>
+          </a:p>
+        </p:txBody>
+      </p:sp>
+      <p:sp>
+        <p:nvSpPr>
+          <p:cNvPr id="18" name="TextBox 17"/>
+          <p:cNvSpPr txBox="1"/>
+          <p:nvPr/>
+        </p:nvSpPr>
+        <p:spPr>
+          <a:xfrm>
+            <a:off x="8983980" y="6941820"/>
+            <a:ext cx="428625" cy="285750"/>
+          </a:xfrm>
+          <a:prstGeom prst="rect">
+            <a:avLst/>
+          </a:prstGeom>
+          <a:noFill/>
+        </p:spPr>
+        <p:txBody>
+          <a:bodyPr wrap="square" anchor="t">
+            <a:spAutoFit/>
+          </a:bodyPr>
+          <a:lstStyle/>
+          <a:p>
+            <a:pPr algn="l"/>
+            <a:r>
+              <a:rPr sz="1650" b="1">
+                <a:solidFill>
+                  <a:srgbClr val="F59E0B"/>
+                </a:solidFill>
+                <a:latin typeface="Montserrat"/>
+              </a:rPr>
+              <a:t>03</a:t>
+            </a:r>
+          </a:p>
+        </p:txBody>
+      </p:sp>
+      <p:sp>
+        <p:nvSpPr>
+          <p:cNvPr id="19" name="TextBox 18"/>
+          <p:cNvSpPr txBox="1"/>
+          <p:nvPr/>
+        </p:nvSpPr>
+        <p:spPr>
+          <a:xfrm>
+            <a:off x="9507855" y="6941820"/>
+            <a:ext cx="7970520" cy="285750"/>
+          </a:xfrm>
+          <a:prstGeom prst="rect">
+            <a:avLst/>
+          </a:prstGeom>
+          <a:noFill/>
+        </p:spPr>
+        <p:txBody>
+          <a:bodyPr wrap="square" anchor="t">
+            <a:spAutoFit/>
+          </a:bodyPr>
+          <a:lstStyle/>
+          <a:p>
+            <a:pPr algn="l"/>
+            <a:r>
+              <a:rPr sz="1575" b="1">
+                <a:solidFill>
+                  <a:srgbClr val="F8FAFC"/>
+                </a:solidFill>
+                <a:latin typeface="Montserrat"/>
+              </a:rPr>
+              <a:t>Konektor API Instan</a:t>
+            </a:r>
+          </a:p>
+        </p:txBody>
+      </p:sp>
+      <p:sp>
+        <p:nvSpPr>
+          <p:cNvPr id="20" name="TextBox 19"/>
+          <p:cNvSpPr txBox="1"/>
+          <p:nvPr/>
+        </p:nvSpPr>
+        <p:spPr>
+          <a:xfrm>
+            <a:off x="9507855" y="7284720"/>
+            <a:ext cx="7970520" cy="571500"/>
+          </a:xfrm>
+          <a:prstGeom prst="rect">
+            <a:avLst/>
+          </a:prstGeom>
+          <a:noFill/>
+        </p:spPr>
+        <p:txBody>
+          <a:bodyPr wrap="square" anchor="t">
+            <a:spAutoFit/>
+          </a:bodyPr>
+          <a:lstStyle/>
+          <a:p>
+            <a:pPr algn="l"/>
+            <a:r>
+              <a:rPr sz="1125" b="0">
+                <a:solidFill>
+                  <a:srgbClr val="94A3B8"/>
+                </a:solidFill>
+                <a:latin typeface="Montserrat"/>
+              </a:rPr>
+              <a:t>Integrasi modular yang mudah disematkan pada sistem yang sedang beroperasi tanpa penghentian layanan.</a:t>
+            </a:r>
           </a:p>
         </p:txBody>
       </p:sp>
@@ -5173,7 +5681,7 @@
     <p:bg>
       <p:bgPr>
         <a:solidFill>
-          <a:srgbClr val="111111"/>
+          <a:srgbClr val="0B0F19"/>
         </a:solidFill>
         <a:effectLst/>
       </p:bgPr>
@@ -5254,7 +5762,7 @@
             <a:r>
               <a:rPr sz="1050" b="1">
                 <a:solidFill>
-                  <a:srgbClr val="FFD400"/>
+                  <a:srgbClr val="0EA5E9"/>
                 </a:solidFill>
                 <a:latin typeface="Montserrat"/>
               </a:rPr>
@@ -5312,7 +5820,9 @@
           <a:prstGeom prst="rect">
             <a:avLst/>
           </a:prstGeom>
-          <a:noFill/>
+          <a:solidFill>
+            <a:srgbClr val="162032"/>
+          </a:solidFill>
           <a:ln w="9525">
             <a:solidFill>
               <a:srgbClr val="334155"/>
@@ -5350,13 +5860,13 @@
         <p:spPr>
           <a:xfrm>
             <a:off x="619125" y="3291840"/>
-            <a:ext cx="5556250" cy="38100"/>
+            <a:ext cx="5556250" cy="47625"/>
           </a:xfrm>
           <a:prstGeom prst="rect">
             <a:avLst/>
           </a:prstGeom>
           <a:solidFill>
-            <a:srgbClr val="FFD400"/>
+            <a:srgbClr val="0EA5E9"/>
           </a:solidFill>
           <a:ln>
             <a:noFill/>
@@ -5408,9 +5918,9 @@
           <a:p>
             <a:pPr algn="l"/>
             <a:r>
-              <a:rPr sz="3900" b="1">
-                <a:solidFill>
-                  <a:srgbClr val="FFD400"/>
+              <a:rPr sz="4050" b="1">
+                <a:solidFill>
+                  <a:srgbClr val="0EA5E9"/>
                 </a:solidFill>
                 <a:latin typeface="Montserrat"/>
               </a:rPr>
@@ -5503,7 +6013,9 @@
           <a:prstGeom prst="rect">
             <a:avLst/>
           </a:prstGeom>
-          <a:noFill/>
+          <a:solidFill>
+            <a:srgbClr val="162032"/>
+          </a:solidFill>
           <a:ln w="9525">
             <a:solidFill>
               <a:srgbClr val="334155"/>
@@ -5541,13 +6053,13 @@
         <p:spPr>
           <a:xfrm>
             <a:off x="6365875" y="3291840"/>
-            <a:ext cx="5556250" cy="38100"/>
+            <a:ext cx="5556250" cy="47625"/>
           </a:xfrm>
           <a:prstGeom prst="rect">
             <a:avLst/>
           </a:prstGeom>
           <a:solidFill>
-            <a:srgbClr val="FFD400"/>
+            <a:srgbClr val="F59E0B"/>
           </a:solidFill>
           <a:ln>
             <a:noFill/>
@@ -5599,9 +6111,9 @@
           <a:p>
             <a:pPr algn="l"/>
             <a:r>
-              <a:rPr sz="3900" b="1">
-                <a:solidFill>
-                  <a:srgbClr val="FFD400"/>
+              <a:rPr sz="4050" b="1">
+                <a:solidFill>
+                  <a:srgbClr val="F59E0B"/>
                 </a:solidFill>
                 <a:latin typeface="Montserrat"/>
               </a:rPr>
@@ -5694,7 +6206,9 @@
           <a:prstGeom prst="rect">
             <a:avLst/>
           </a:prstGeom>
-          <a:noFill/>
+          <a:solidFill>
+            <a:srgbClr val="162032"/>
+          </a:solidFill>
           <a:ln w="9525">
             <a:solidFill>
               <a:srgbClr val="334155"/>
@@ -5732,13 +6246,13 @@
         <p:spPr>
           <a:xfrm>
             <a:off x="12112625" y="3291840"/>
-            <a:ext cx="5556250" cy="38100"/>
+            <a:ext cx="5556250" cy="47625"/>
           </a:xfrm>
           <a:prstGeom prst="rect">
             <a:avLst/>
           </a:prstGeom>
           <a:solidFill>
-            <a:srgbClr val="FFD400"/>
+            <a:srgbClr val="0EA5E9"/>
           </a:solidFill>
           <a:ln>
             <a:noFill/>
@@ -5790,9 +6304,9 @@
           <a:p>
             <a:pPr algn="l"/>
             <a:r>
-              <a:rPr sz="3900" b="1">
-                <a:solidFill>
-                  <a:srgbClr val="FFD400"/>
+              <a:rPr sz="4050" b="1">
+                <a:solidFill>
+                  <a:srgbClr val="0EA5E9"/>
                 </a:solidFill>
                 <a:latin typeface="Montserrat"/>
               </a:rPr>
@@ -5885,7 +6399,7 @@
     <p:bg>
       <p:bgPr>
         <a:solidFill>
-          <a:srgbClr val="111111"/>
+          <a:srgbClr val="0B0F19"/>
         </a:solidFill>
         <a:effectLst/>
       </p:bgPr>
@@ -5966,7 +6480,7 @@
             <a:r>
               <a:rPr sz="1050" b="1">
                 <a:solidFill>
-                  <a:srgbClr val="FF3B30"/>
+                  <a:srgbClr val="F59E0B"/>
                 </a:solidFill>
                 <a:latin typeface="Montserrat"/>
               </a:rPr>
@@ -6053,17 +6567,19 @@
         </p:nvSpPr>
         <p:spPr>
           <a:xfrm>
-            <a:off x="619125" y="5349240"/>
-            <a:ext cx="17049750" cy="9525"/>
+            <a:off x="619125" y="5554980"/>
+            <a:ext cx="17049750" cy="3291840"/>
           </a:xfrm>
           <a:prstGeom prst="rect">
             <a:avLst/>
           </a:prstGeom>
           <a:solidFill>
-            <a:srgbClr val="334155"/>
+            <a:srgbClr val="162032"/>
           </a:solidFill>
-          <a:ln>
-            <a:noFill/>
+          <a:ln w="9525">
+            <a:solidFill>
+              <a:srgbClr val="334155"/>
+            </a:solidFill>
           </a:ln>
         </p:spPr>
         <p:style>
@@ -6096,7 +6612,7 @@
         </p:nvSpPr>
         <p:spPr>
           <a:xfrm>
-            <a:off x="619125" y="5966460"/>
+            <a:off x="923925" y="5966460"/>
             <a:ext cx="3810000" cy="247650"/>
           </a:xfrm>
           <a:prstGeom prst="rect">
@@ -6114,7 +6630,7 @@
             <a:r>
               <a:rPr sz="1050" b="1">
                 <a:solidFill>
-                  <a:srgbClr val="FFD400"/>
+                  <a:srgbClr val="0EA5E9"/>
                 </a:solidFill>
                 <a:latin typeface="Montserrat"/>
               </a:rPr>
@@ -6131,7 +6647,7 @@
         </p:nvSpPr>
         <p:spPr>
           <a:xfrm>
-            <a:off x="619125" y="6583680"/>
+            <a:off x="923925" y="6583680"/>
             <a:ext cx="8229600" cy="571500"/>
           </a:xfrm>
           <a:prstGeom prst="rect">
@@ -6178,7 +6694,7 @@
         </p:nvSpPr>
         <p:spPr>
           <a:xfrm>
-            <a:off x="619125" y="7715250"/>
+            <a:off x="923925" y="7818120"/>
             <a:ext cx="8229600" cy="285750"/>
           </a:xfrm>
           <a:prstGeom prst="rect">
@@ -6213,14 +6729,14 @@
         </p:nvSpPr>
         <p:spPr>
           <a:xfrm>
-            <a:off x="14620875" y="6480810"/>
-            <a:ext cx="3048000" cy="533400"/>
+            <a:off x="14430375" y="6583680"/>
+            <a:ext cx="2857500" cy="533400"/>
           </a:xfrm>
           <a:prstGeom prst="rect">
             <a:avLst/>
           </a:prstGeom>
           <a:solidFill>
-            <a:srgbClr val="FFD400"/>
+            <a:srgbClr val="0EA5E9"/>
           </a:solidFill>
           <a:ln>
             <a:noFill/>
@@ -6256,8 +6772,8 @@
         </p:nvSpPr>
         <p:spPr>
           <a:xfrm>
-            <a:off x="14620875" y="6633210"/>
-            <a:ext cx="3048000" cy="285750"/>
+            <a:off x="14430375" y="6736080"/>
+            <a:ext cx="2857500" cy="285750"/>
           </a:xfrm>
           <a:prstGeom prst="rect">
             <a:avLst/>

</xml_diff>